<commit_message>
Tesla earnings update: list status as a disclosure line under the dateline
Co-Authored-By: Claude Opus 5.5 <noreply@anthropic.com>
Claude-Session: https://claude.ai/code/session_01N4CkkntnhRz2pC9J6acWNT
</commit_message>
<xml_diff>
--- a/notes/2026-10-21-tesla-q3-results/syz-earnings/out/Earnings_Update_TSLA_Q32026.pptx
+++ b/notes/2026-10-21-tesla-q3-results/syz-earnings/out/Earnings_Update_TSLA_Q32026.pptx
@@ -1301,13 +1301,55 @@
       </p:sp>
       <p:sp>
         <p:nvSpPr>
-          <p:cNvPr id="9" name="Shape 5"/>
+          <p:cNvPr id="9" name="Text 5"/>
+          <p:cNvSpPr txBox="1"/>
+          <p:nvPr/>
+        </p:nvSpPr>
+        <p:spPr>
+          <a:xfrm>
+            <a:off x="539496" y="1538986"/>
+            <a:ext cx="6483096" cy="140335"/>
+          </a:xfrm>
+          <a:prstGeom prst="rect">
+            <a:avLst/>
+          </a:prstGeom>
+          <a:noFill/>
+          <a:ln/>
+        </p:spPr>
+        <p:txBody>
+          <a:bodyPr wrap="square" lIns="0" tIns="0" rIns="0" bIns="0" rtlCol="0" anchor="t"/>
+          <a:lstStyle/>
+          <a:p>
+            <a:pPr indent="0" marL="0">
+              <a:lnSpc>
+                <a:spcPct val="108333"/>
+              </a:lnSpc>
+              <a:buNone/>
+            </a:pPr>
+            <a:r>
+              <a:rPr lang="en-US" sz="850" b="1" dirty="0">
+                <a:solidFill>
+                  <a:srgbClr val="FF6C0E"/>
+                </a:solidFill>
+                <a:latin typeface="Nunito" pitchFamily="34" charset="0"/>
+                <a:ea typeface="Nunito" pitchFamily="34" charset="-122"/>
+                <a:cs typeface="Nunito" pitchFamily="34" charset="-120"/>
+              </a:rPr>
+              <a:t>Tesla is on neither the Syz master list nor the focus list, and this update is not a recommendation to buy the share.</a:t>
+            </a:r>
+            <a:endParaRPr lang="en-US" sz="850" dirty="0"/>
+          </a:p>
+        </p:txBody>
+      </p:sp>
+      <p:sp>
+        <p:nvSpPr>
+          <p:cNvPr id="10" name="Shape 6"/>
           <p:cNvSpPr/>
           <p:nvPr/>
         </p:nvSpPr>
         <p:spPr>
           <a:xfrm>
-            <a:off x="539496" y="1612138"/>
+            <a:off x="539496" y="1798193"/>
             <a:ext cx="42977" cy="573786"/>
           </a:xfrm>
           <a:prstGeom prst="rect">
@@ -1326,13 +1368,13 @@
       </p:sp>
       <p:sp>
         <p:nvSpPr>
-          <p:cNvPr id="10" name="Text 6"/>
-          <p:cNvSpPr txBox="1"/>
-          <p:nvPr/>
-        </p:nvSpPr>
-        <p:spPr>
-          <a:xfrm>
-            <a:off x="722376" y="1630426"/>
+          <p:cNvPr id="11" name="Text 7"/>
+          <p:cNvSpPr txBox="1"/>
+          <p:nvPr/>
+        </p:nvSpPr>
+        <p:spPr>
+          <a:xfrm>
+            <a:off x="722376" y="1816481"/>
             <a:ext cx="6300216" cy="336042"/>
           </a:xfrm>
           <a:prstGeom prst="rect">
@@ -1368,13 +1410,13 @@
       </p:sp>
       <p:sp>
         <p:nvSpPr>
-          <p:cNvPr id="11" name="Text 7"/>
-          <p:cNvSpPr txBox="1"/>
-          <p:nvPr/>
-        </p:nvSpPr>
-        <p:spPr>
-          <a:xfrm>
-            <a:off x="722376" y="2003044"/>
+          <p:cNvPr id="12" name="Text 8"/>
+          <p:cNvSpPr txBox="1"/>
+          <p:nvPr/>
+        </p:nvSpPr>
+        <p:spPr>
+          <a:xfrm>
+            <a:off x="722376" y="2189099"/>
             <a:ext cx="6300216" cy="155448"/>
           </a:xfrm>
           <a:prstGeom prst="rect">
@@ -1407,13 +1449,13 @@
       </p:sp>
       <p:sp>
         <p:nvSpPr>
-          <p:cNvPr id="12" name="Text 8"/>
-          <p:cNvSpPr txBox="1"/>
-          <p:nvPr/>
-        </p:nvSpPr>
-        <p:spPr>
-          <a:xfrm>
-            <a:off x="539496" y="2304796"/>
+          <p:cNvPr id="13" name="Text 9"/>
+          <p:cNvSpPr txBox="1"/>
+          <p:nvPr/>
+        </p:nvSpPr>
+        <p:spPr>
+          <a:xfrm>
+            <a:off x="539496" y="2490851"/>
             <a:ext cx="6483096" cy="219456"/>
           </a:xfrm>
           <a:prstGeom prst="rect">
@@ -1446,13 +1488,13 @@
       </p:sp>
       <p:sp>
         <p:nvSpPr>
-          <p:cNvPr id="13" name="Text 9"/>
-          <p:cNvSpPr txBox="1"/>
-          <p:nvPr/>
-        </p:nvSpPr>
-        <p:spPr>
-          <a:xfrm>
-            <a:off x="539496" y="2565400"/>
+          <p:cNvPr id="14" name="Text 10"/>
+          <p:cNvSpPr txBox="1"/>
+          <p:nvPr/>
+        </p:nvSpPr>
+        <p:spPr>
+          <a:xfrm>
+            <a:off x="539496" y="2751455"/>
             <a:ext cx="576072" cy="156896"/>
           </a:xfrm>
           <a:prstGeom prst="rect">
@@ -1485,13 +1527,13 @@
       </p:sp>
       <p:sp>
         <p:nvSpPr>
-          <p:cNvPr id="14" name="Text 10"/>
-          <p:cNvSpPr txBox="1"/>
-          <p:nvPr/>
-        </p:nvSpPr>
-        <p:spPr>
-          <a:xfrm>
-            <a:off x="1133856" y="2542540"/>
+          <p:cNvPr id="15" name="Text 11"/>
+          <p:cNvSpPr txBox="1"/>
+          <p:nvPr/>
+        </p:nvSpPr>
+        <p:spPr>
+          <a:xfrm>
+            <a:off x="1133856" y="2728595"/>
             <a:ext cx="5888736" cy="156896"/>
           </a:xfrm>
           <a:prstGeom prst="rect">
@@ -1527,13 +1569,13 @@
       </p:sp>
       <p:sp>
         <p:nvSpPr>
-          <p:cNvPr id="15" name="Text 11"/>
-          <p:cNvSpPr txBox="1"/>
-          <p:nvPr/>
-        </p:nvSpPr>
-        <p:spPr>
-          <a:xfrm>
-            <a:off x="539496" y="2768016"/>
+          <p:cNvPr id="16" name="Text 12"/>
+          <p:cNvSpPr txBox="1"/>
+          <p:nvPr/>
+        </p:nvSpPr>
+        <p:spPr>
+          <a:xfrm>
+            <a:off x="539496" y="2954071"/>
             <a:ext cx="576072" cy="156896"/>
           </a:xfrm>
           <a:prstGeom prst="rect">
@@ -1566,13 +1608,13 @@
       </p:sp>
       <p:sp>
         <p:nvSpPr>
-          <p:cNvPr id="16" name="Text 12"/>
-          <p:cNvSpPr txBox="1"/>
-          <p:nvPr/>
-        </p:nvSpPr>
-        <p:spPr>
-          <a:xfrm>
-            <a:off x="1133856" y="2745156"/>
+          <p:cNvPr id="17" name="Text 13"/>
+          <p:cNvSpPr txBox="1"/>
+          <p:nvPr/>
+        </p:nvSpPr>
+        <p:spPr>
+          <a:xfrm>
+            <a:off x="1133856" y="2931211"/>
             <a:ext cx="5888736" cy="156896"/>
           </a:xfrm>
           <a:prstGeom prst="rect">
@@ -1608,13 +1650,13 @@
       </p:sp>
       <p:sp>
         <p:nvSpPr>
-          <p:cNvPr id="17" name="Text 13"/>
-          <p:cNvSpPr txBox="1"/>
-          <p:nvPr/>
-        </p:nvSpPr>
-        <p:spPr>
-          <a:xfrm>
-            <a:off x="539496" y="2970632"/>
+          <p:cNvPr id="18" name="Text 14"/>
+          <p:cNvSpPr txBox="1"/>
+          <p:nvPr/>
+        </p:nvSpPr>
+        <p:spPr>
+          <a:xfrm>
+            <a:off x="539496" y="3156687"/>
             <a:ext cx="576072" cy="156896"/>
           </a:xfrm>
           <a:prstGeom prst="rect">
@@ -1647,13 +1689,13 @@
       </p:sp>
       <p:sp>
         <p:nvSpPr>
-          <p:cNvPr id="18" name="Text 14"/>
-          <p:cNvSpPr txBox="1"/>
-          <p:nvPr/>
-        </p:nvSpPr>
-        <p:spPr>
-          <a:xfrm>
-            <a:off x="1133856" y="2947772"/>
+          <p:cNvPr id="19" name="Text 15"/>
+          <p:cNvSpPr txBox="1"/>
+          <p:nvPr/>
+        </p:nvSpPr>
+        <p:spPr>
+          <a:xfrm>
+            <a:off x="1133856" y="3133827"/>
             <a:ext cx="5888736" cy="156896"/>
           </a:xfrm>
           <a:prstGeom prst="rect">
@@ -1689,13 +1731,13 @@
       </p:sp>
       <p:sp>
         <p:nvSpPr>
-          <p:cNvPr id="19" name="Text 15"/>
-          <p:cNvSpPr txBox="1"/>
-          <p:nvPr/>
-        </p:nvSpPr>
-        <p:spPr>
-          <a:xfrm>
-            <a:off x="539496" y="3173247"/>
+          <p:cNvPr id="20" name="Text 16"/>
+          <p:cNvSpPr txBox="1"/>
+          <p:nvPr/>
+        </p:nvSpPr>
+        <p:spPr>
+          <a:xfrm>
+            <a:off x="539496" y="3359302"/>
             <a:ext cx="576072" cy="156896"/>
           </a:xfrm>
           <a:prstGeom prst="rect">
@@ -1728,13 +1770,13 @@
       </p:sp>
       <p:sp>
         <p:nvSpPr>
-          <p:cNvPr id="20" name="Text 16"/>
-          <p:cNvSpPr txBox="1"/>
-          <p:nvPr/>
-        </p:nvSpPr>
-        <p:spPr>
-          <a:xfrm>
-            <a:off x="1133856" y="3150387"/>
+          <p:cNvPr id="21" name="Text 17"/>
+          <p:cNvSpPr txBox="1"/>
+          <p:nvPr/>
+        </p:nvSpPr>
+        <p:spPr>
+          <a:xfrm>
+            <a:off x="1133856" y="3336442"/>
             <a:ext cx="5888736" cy="156896"/>
           </a:xfrm>
           <a:prstGeom prst="rect">
@@ -1770,13 +1812,13 @@
       </p:sp>
       <p:sp>
         <p:nvSpPr>
-          <p:cNvPr id="21" name="Shape 17"/>
+          <p:cNvPr id="22" name="Shape 18"/>
           <p:cNvSpPr/>
           <p:nvPr/>
         </p:nvSpPr>
         <p:spPr>
           <a:xfrm>
-            <a:off x="539496" y="3435299"/>
+            <a:off x="539496" y="3621354"/>
             <a:ext cx="6483096" cy="676656"/>
           </a:xfrm>
           <a:prstGeom prst="rect">
@@ -1795,13 +1837,13 @@
       </p:sp>
       <p:sp>
         <p:nvSpPr>
-          <p:cNvPr id="22" name="Text 18"/>
-          <p:cNvSpPr txBox="1"/>
-          <p:nvPr/>
-        </p:nvSpPr>
-        <p:spPr>
-          <a:xfrm>
-            <a:off x="649224" y="3517595"/>
+          <p:cNvPr id="23" name="Text 19"/>
+          <p:cNvSpPr txBox="1"/>
+          <p:nvPr/>
+        </p:nvSpPr>
+        <p:spPr>
+          <a:xfrm>
+            <a:off x="649224" y="3703650"/>
             <a:ext cx="1437894" cy="146304"/>
           </a:xfrm>
           <a:prstGeom prst="rect">
@@ -1834,13 +1876,13 @@
       </p:sp>
       <p:sp>
         <p:nvSpPr>
-          <p:cNvPr id="23" name="Text 19"/>
-          <p:cNvSpPr txBox="1"/>
-          <p:nvPr/>
-        </p:nvSpPr>
-        <p:spPr>
-          <a:xfrm>
-            <a:off x="649224" y="3663899"/>
+          <p:cNvPr id="24" name="Text 20"/>
+          <p:cNvSpPr txBox="1"/>
+          <p:nvPr/>
+        </p:nvSpPr>
+        <p:spPr>
+          <a:xfrm>
+            <a:off x="649224" y="3849954"/>
             <a:ext cx="1437894" cy="237744"/>
           </a:xfrm>
           <a:prstGeom prst="rect">
@@ -1873,13 +1915,13 @@
       </p:sp>
       <p:sp>
         <p:nvSpPr>
-          <p:cNvPr id="24" name="Text 20"/>
-          <p:cNvSpPr txBox="1"/>
-          <p:nvPr/>
-        </p:nvSpPr>
-        <p:spPr>
-          <a:xfrm>
-            <a:off x="649224" y="3901643"/>
+          <p:cNvPr id="25" name="Text 21"/>
+          <p:cNvSpPr txBox="1"/>
+          <p:nvPr/>
+        </p:nvSpPr>
+        <p:spPr>
+          <a:xfrm>
+            <a:off x="649224" y="4087698"/>
             <a:ext cx="1437894" cy="146304"/>
           </a:xfrm>
           <a:prstGeom prst="rect">
@@ -1912,13 +1954,13 @@
       </p:sp>
       <p:sp>
         <p:nvSpPr>
-          <p:cNvPr id="25" name="Shape 21"/>
+          <p:cNvPr id="26" name="Shape 22"/>
           <p:cNvSpPr/>
           <p:nvPr/>
         </p:nvSpPr>
         <p:spPr>
           <a:xfrm>
-            <a:off x="2160270" y="3435299"/>
+            <a:off x="2160270" y="3621354"/>
             <a:ext cx="0" cy="676656"/>
           </a:xfrm>
           <a:prstGeom prst="line">
@@ -1935,13 +1977,13 @@
       </p:sp>
       <p:sp>
         <p:nvSpPr>
-          <p:cNvPr id="26" name="Text 22"/>
-          <p:cNvSpPr txBox="1"/>
-          <p:nvPr/>
-        </p:nvSpPr>
-        <p:spPr>
-          <a:xfrm>
-            <a:off x="2269998" y="3517595"/>
+          <p:cNvPr id="27" name="Text 23"/>
+          <p:cNvSpPr txBox="1"/>
+          <p:nvPr/>
+        </p:nvSpPr>
+        <p:spPr>
+          <a:xfrm>
+            <a:off x="2269998" y="3703650"/>
             <a:ext cx="1437894" cy="146304"/>
           </a:xfrm>
           <a:prstGeom prst="rect">
@@ -1974,13 +2016,13 @@
       </p:sp>
       <p:sp>
         <p:nvSpPr>
-          <p:cNvPr id="27" name="Text 23"/>
-          <p:cNvSpPr txBox="1"/>
-          <p:nvPr/>
-        </p:nvSpPr>
-        <p:spPr>
-          <a:xfrm>
-            <a:off x="2269998" y="3663899"/>
+          <p:cNvPr id="28" name="Text 24"/>
+          <p:cNvSpPr txBox="1"/>
+          <p:nvPr/>
+        </p:nvSpPr>
+        <p:spPr>
+          <a:xfrm>
+            <a:off x="2269998" y="3849954"/>
             <a:ext cx="1437894" cy="237744"/>
           </a:xfrm>
           <a:prstGeom prst="rect">
@@ -2013,13 +2055,13 @@
       </p:sp>
       <p:sp>
         <p:nvSpPr>
-          <p:cNvPr id="28" name="Text 24"/>
-          <p:cNvSpPr txBox="1"/>
-          <p:nvPr/>
-        </p:nvSpPr>
-        <p:spPr>
-          <a:xfrm>
-            <a:off x="2269998" y="3901643"/>
+          <p:cNvPr id="29" name="Text 25"/>
+          <p:cNvSpPr txBox="1"/>
+          <p:nvPr/>
+        </p:nvSpPr>
+        <p:spPr>
+          <a:xfrm>
+            <a:off x="2269998" y="4087698"/>
             <a:ext cx="1437894" cy="146304"/>
           </a:xfrm>
           <a:prstGeom prst="rect">
@@ -2052,13 +2094,13 @@
       </p:sp>
       <p:sp>
         <p:nvSpPr>
-          <p:cNvPr id="29" name="Shape 25"/>
+          <p:cNvPr id="30" name="Shape 26"/>
           <p:cNvSpPr/>
           <p:nvPr/>
         </p:nvSpPr>
         <p:spPr>
           <a:xfrm>
-            <a:off x="3781044" y="3435299"/>
+            <a:off x="3781044" y="3621354"/>
             <a:ext cx="0" cy="676656"/>
           </a:xfrm>
           <a:prstGeom prst="line">
@@ -2075,13 +2117,13 @@
       </p:sp>
       <p:sp>
         <p:nvSpPr>
-          <p:cNvPr id="30" name="Text 26"/>
-          <p:cNvSpPr txBox="1"/>
-          <p:nvPr/>
-        </p:nvSpPr>
-        <p:spPr>
-          <a:xfrm>
-            <a:off x="3890772" y="3517595"/>
+          <p:cNvPr id="31" name="Text 27"/>
+          <p:cNvSpPr txBox="1"/>
+          <p:nvPr/>
+        </p:nvSpPr>
+        <p:spPr>
+          <a:xfrm>
+            <a:off x="3890772" y="3703650"/>
             <a:ext cx="1437894" cy="146304"/>
           </a:xfrm>
           <a:prstGeom prst="rect">
@@ -2114,13 +2156,13 @@
       </p:sp>
       <p:sp>
         <p:nvSpPr>
-          <p:cNvPr id="31" name="Text 27"/>
-          <p:cNvSpPr txBox="1"/>
-          <p:nvPr/>
-        </p:nvSpPr>
-        <p:spPr>
-          <a:xfrm>
-            <a:off x="3890772" y="3663899"/>
+          <p:cNvPr id="32" name="Text 28"/>
+          <p:cNvSpPr txBox="1"/>
+          <p:nvPr/>
+        </p:nvSpPr>
+        <p:spPr>
+          <a:xfrm>
+            <a:off x="3890772" y="3849954"/>
             <a:ext cx="1437894" cy="237744"/>
           </a:xfrm>
           <a:prstGeom prst="rect">
@@ -2153,13 +2195,13 @@
       </p:sp>
       <p:sp>
         <p:nvSpPr>
-          <p:cNvPr id="32" name="Text 28"/>
-          <p:cNvSpPr txBox="1"/>
-          <p:nvPr/>
-        </p:nvSpPr>
-        <p:spPr>
-          <a:xfrm>
-            <a:off x="3890772" y="3901643"/>
+          <p:cNvPr id="33" name="Text 29"/>
+          <p:cNvSpPr txBox="1"/>
+          <p:nvPr/>
+        </p:nvSpPr>
+        <p:spPr>
+          <a:xfrm>
+            <a:off x="3890772" y="4087698"/>
             <a:ext cx="1437894" cy="146304"/>
           </a:xfrm>
           <a:prstGeom prst="rect">
@@ -2192,13 +2234,13 @@
       </p:sp>
       <p:sp>
         <p:nvSpPr>
-          <p:cNvPr id="33" name="Shape 29"/>
+          <p:cNvPr id="34" name="Shape 30"/>
           <p:cNvSpPr/>
           <p:nvPr/>
         </p:nvSpPr>
         <p:spPr>
           <a:xfrm>
-            <a:off x="5401818" y="3435299"/>
+            <a:off x="5401818" y="3621354"/>
             <a:ext cx="0" cy="676656"/>
           </a:xfrm>
           <a:prstGeom prst="line">
@@ -2215,13 +2257,13 @@
       </p:sp>
       <p:sp>
         <p:nvSpPr>
-          <p:cNvPr id="34" name="Text 30"/>
-          <p:cNvSpPr txBox="1"/>
-          <p:nvPr/>
-        </p:nvSpPr>
-        <p:spPr>
-          <a:xfrm>
-            <a:off x="5511546" y="3517595"/>
+          <p:cNvPr id="35" name="Text 31"/>
+          <p:cNvSpPr txBox="1"/>
+          <p:nvPr/>
+        </p:nvSpPr>
+        <p:spPr>
+          <a:xfrm>
+            <a:off x="5511546" y="3703650"/>
             <a:ext cx="1437894" cy="146304"/>
           </a:xfrm>
           <a:prstGeom prst="rect">
@@ -2254,13 +2296,13 @@
       </p:sp>
       <p:sp>
         <p:nvSpPr>
-          <p:cNvPr id="35" name="Text 31"/>
-          <p:cNvSpPr txBox="1"/>
-          <p:nvPr/>
-        </p:nvSpPr>
-        <p:spPr>
-          <a:xfrm>
-            <a:off x="5511546" y="3663899"/>
+          <p:cNvPr id="36" name="Text 32"/>
+          <p:cNvSpPr txBox="1"/>
+          <p:nvPr/>
+        </p:nvSpPr>
+        <p:spPr>
+          <a:xfrm>
+            <a:off x="5511546" y="3849954"/>
             <a:ext cx="1437894" cy="237744"/>
           </a:xfrm>
           <a:prstGeom prst="rect">
@@ -2293,13 +2335,13 @@
       </p:sp>
       <p:sp>
         <p:nvSpPr>
-          <p:cNvPr id="36" name="Text 32"/>
-          <p:cNvSpPr txBox="1"/>
-          <p:nvPr/>
-        </p:nvSpPr>
-        <p:spPr>
-          <a:xfrm>
-            <a:off x="5511546" y="3901643"/>
+          <p:cNvPr id="37" name="Text 33"/>
+          <p:cNvSpPr txBox="1"/>
+          <p:nvPr/>
+        </p:nvSpPr>
+        <p:spPr>
+          <a:xfrm>
+            <a:off x="5511546" y="4087698"/>
             <a:ext cx="1437894" cy="146304"/>
           </a:xfrm>
           <a:prstGeom prst="rect">
@@ -2332,13 +2374,13 @@
       </p:sp>
       <p:sp>
         <p:nvSpPr>
-          <p:cNvPr id="37" name="Text 33"/>
-          <p:cNvSpPr txBox="1"/>
-          <p:nvPr/>
-        </p:nvSpPr>
-        <p:spPr>
-          <a:xfrm>
-            <a:off x="539496" y="4230827"/>
+          <p:cNvPr id="38" name="Text 34"/>
+          <p:cNvSpPr txBox="1"/>
+          <p:nvPr/>
+        </p:nvSpPr>
+        <p:spPr>
+          <a:xfrm>
+            <a:off x="539496" y="4416882"/>
             <a:ext cx="6483096" cy="219456"/>
           </a:xfrm>
           <a:prstGeom prst="rect">
@@ -2371,13 +2413,13 @@
       </p:sp>
       <p:sp>
         <p:nvSpPr>
-          <p:cNvPr id="38" name="Text 34"/>
-          <p:cNvSpPr txBox="1"/>
-          <p:nvPr/>
-        </p:nvSpPr>
-        <p:spPr>
-          <a:xfrm>
-            <a:off x="539496" y="4477715"/>
+          <p:cNvPr id="39" name="Text 35"/>
+          <p:cNvSpPr txBox="1"/>
+          <p:nvPr/>
+        </p:nvSpPr>
+        <p:spPr>
+          <a:xfrm>
+            <a:off x="539496" y="4663770"/>
             <a:ext cx="6483096" cy="645871"/>
           </a:xfrm>
           <a:prstGeom prst="rect">
@@ -2413,13 +2455,13 @@
       </p:sp>
       <p:sp>
         <p:nvSpPr>
-          <p:cNvPr id="39" name="Text 35"/>
-          <p:cNvSpPr txBox="1"/>
-          <p:nvPr/>
-        </p:nvSpPr>
-        <p:spPr>
-          <a:xfrm>
-            <a:off x="539496" y="5203139"/>
+          <p:cNvPr id="40" name="Text 36"/>
+          <p:cNvSpPr txBox="1"/>
+          <p:nvPr/>
+        </p:nvSpPr>
+        <p:spPr>
+          <a:xfrm>
+            <a:off x="539496" y="5389194"/>
             <a:ext cx="6483096" cy="182880"/>
           </a:xfrm>
           <a:prstGeom prst="rect">
@@ -2466,13 +2508,13 @@
       </p:sp>
       <p:sp>
         <p:nvSpPr>
-          <p:cNvPr id="40" name="Text 36"/>
-          <p:cNvSpPr txBox="1"/>
-          <p:nvPr/>
-        </p:nvSpPr>
-        <p:spPr>
-          <a:xfrm>
-            <a:off x="539496" y="5386019"/>
+          <p:cNvPr id="41" name="Text 37"/>
+          <p:cNvSpPr txBox="1"/>
+          <p:nvPr/>
+        </p:nvSpPr>
+        <p:spPr>
+          <a:xfrm>
+            <a:off x="539496" y="5572074"/>
             <a:ext cx="6483096" cy="118872"/>
           </a:xfrm>
           <a:prstGeom prst="rect">
@@ -2508,7 +2550,7 @@
       </p:sp>
       <p:pic>
         <p:nvPicPr>
-          <p:cNvPr id="41" name="Image 2" descr="/home/user/adhoc_Equity/notes/2026-10-21-tesla-q3-results/syz-earnings/out/c1_crop.png">    </p:cNvPr>
+          <p:cNvPr id="42" name="Image 2" descr="/home/user/adhoc_Equity/notes/2026-10-21-tesla-q3-results/syz-earnings/out/c1_crop.png">    </p:cNvPr>
           <p:cNvPicPr>
             <a:picLocks noChangeAspect="1"/>
           </p:cNvPicPr>
@@ -2522,7 +2564,7 @@
         </p:blipFill>
         <p:spPr>
           <a:xfrm>
-            <a:off x="1641622" y="5550611"/>
+            <a:off x="1641622" y="5736666"/>
             <a:ext cx="4278843" cy="1334999"/>
           </a:xfrm>
           <a:prstGeom prst="rect">
@@ -2532,13 +2574,13 @@
       </p:pic>
       <p:sp>
         <p:nvSpPr>
-          <p:cNvPr id="42" name="Text 37"/>
-          <p:cNvSpPr txBox="1"/>
-          <p:nvPr/>
-        </p:nvSpPr>
-        <p:spPr>
-          <a:xfrm>
-            <a:off x="539496" y="6940474"/>
+          <p:cNvPr id="43" name="Text 38"/>
+          <p:cNvSpPr txBox="1"/>
+          <p:nvPr/>
+        </p:nvSpPr>
+        <p:spPr>
+          <a:xfrm>
+            <a:off x="539496" y="7126529"/>
             <a:ext cx="6483096" cy="488975"/>
           </a:xfrm>
           <a:prstGeom prst="rect">
@@ -2574,13 +2616,13 @@
       </p:sp>
       <p:sp>
         <p:nvSpPr>
-          <p:cNvPr id="43" name="Text 38"/>
-          <p:cNvSpPr txBox="1"/>
-          <p:nvPr/>
-        </p:nvSpPr>
-        <p:spPr>
-          <a:xfrm>
-            <a:off x="539496" y="7545579"/>
+          <p:cNvPr id="44" name="Text 39"/>
+          <p:cNvSpPr txBox="1"/>
+          <p:nvPr/>
+        </p:nvSpPr>
+        <p:spPr>
+          <a:xfrm>
+            <a:off x="539496" y="7731634"/>
             <a:ext cx="6483096" cy="219456"/>
           </a:xfrm>
           <a:prstGeom prst="rect">
@@ -2613,14 +2655,14 @@
       </p:sp>
       <p:sp>
         <p:nvSpPr>
-          <p:cNvPr id="44" name="Text 39"/>
-          <p:cNvSpPr txBox="1"/>
-          <p:nvPr/>
-        </p:nvSpPr>
-        <p:spPr>
-          <a:xfrm>
-            <a:off x="539496" y="7792467"/>
-            <a:ext cx="6483096" cy="959663"/>
+          <p:cNvPr id="45" name="Text 40"/>
+          <p:cNvSpPr txBox="1"/>
+          <p:nvPr/>
+        </p:nvSpPr>
+        <p:spPr>
+          <a:xfrm>
+            <a:off x="539496" y="7978522"/>
+            <a:ext cx="6483096" cy="802767"/>
           </a:xfrm>
           <a:prstGeom prst="rect">
             <a:avLst/>
@@ -2647,7 +2689,7 @@
                 <a:ea typeface="Nunito" pitchFamily="34" charset="-122"/>
                 <a:cs typeface="Nunito" pitchFamily="34" charset="-120"/>
               </a:rPr>
-              <a:t>Our stance on Tesla is neutral and cautious. The share is on neither the Syz master list nor the focus list, and this update is not a recommendation to buy it. The car business is stabilising, with the highest order backlog in four years, but the earnings base remains thin: 12-month forward consensus EPS is only USD 1.73. The valuation rests on autonomy, Optimus and the Terafab chip project, none yet generating revenue at scale, while capex will keep rising. Results move the share sharply: it fell 14.5% after the July print. The next tests are EU approval of Full Self-Driving and Cybercab launches beyond Austin.</a:t>
+              <a:t>Our stance on Tesla is neutral and cautious: USD 1.53bn of free cash flow and over USD 45bn of cash fund the build-out, but do not justify the multiple. The car business is stabilising, with the highest order backlog in four years, but the earnings base remains thin: 12-month forward consensus EPS is only USD 1.73. The valuation rests on autonomy, Optimus and the Terafab chip project, none yet generating revenue at scale, while capex will keep rising. Results move the share sharply: it fell 14.5% after the July print. The next tests are EU approval of Full Self-Driving and Cybercab launches beyond Austin.</a:t>
             </a:r>
             <a:endParaRPr lang="en-US" sz="870" dirty="0"/>
           </a:p>
@@ -2655,13 +2697,13 @@
       </p:sp>
       <p:sp>
         <p:nvSpPr>
-          <p:cNvPr id="45" name="Shape 40"/>
+          <p:cNvPr id="46" name="Shape 41"/>
           <p:cNvSpPr/>
           <p:nvPr/>
         </p:nvSpPr>
         <p:spPr>
           <a:xfrm>
-            <a:off x="3781044" y="8868258"/>
+            <a:off x="3781044" y="8897417"/>
             <a:ext cx="0" cy="985647"/>
           </a:xfrm>
           <a:prstGeom prst="line">
@@ -2678,13 +2720,13 @@
       </p:sp>
       <p:sp>
         <p:nvSpPr>
-          <p:cNvPr id="46" name="Text 41"/>
-          <p:cNvSpPr txBox="1"/>
-          <p:nvPr/>
-        </p:nvSpPr>
-        <p:spPr>
-          <a:xfrm>
-            <a:off x="539496" y="8868258"/>
+          <p:cNvPr id="47" name="Text 42"/>
+          <p:cNvSpPr txBox="1"/>
+          <p:nvPr/>
+        </p:nvSpPr>
+        <p:spPr>
+          <a:xfrm>
+            <a:off x="539496" y="8897417"/>
             <a:ext cx="3058668" cy="155448"/>
           </a:xfrm>
           <a:prstGeom prst="rect">
@@ -2717,13 +2759,13 @@
       </p:sp>
       <p:sp>
         <p:nvSpPr>
-          <p:cNvPr id="47" name="Text 42"/>
-          <p:cNvSpPr txBox="1"/>
-          <p:nvPr/>
-        </p:nvSpPr>
-        <p:spPr>
-          <a:xfrm>
-            <a:off x="539496" y="9060282"/>
+          <p:cNvPr id="48" name="Text 43"/>
+          <p:cNvSpPr txBox="1"/>
+          <p:nvPr/>
+        </p:nvSpPr>
+        <p:spPr>
+          <a:xfrm>
+            <a:off x="539496" y="9089441"/>
             <a:ext cx="3058668" cy="784479"/>
           </a:xfrm>
           <a:prstGeom prst="rect">
@@ -2759,13 +2801,13 @@
       </p:sp>
       <p:sp>
         <p:nvSpPr>
-          <p:cNvPr id="48" name="Text 43"/>
-          <p:cNvSpPr txBox="1"/>
-          <p:nvPr/>
-        </p:nvSpPr>
-        <p:spPr>
-          <a:xfrm>
-            <a:off x="3963924" y="8868258"/>
+          <p:cNvPr id="49" name="Text 44"/>
+          <p:cNvSpPr txBox="1"/>
+          <p:nvPr/>
+        </p:nvSpPr>
+        <p:spPr>
+          <a:xfrm>
+            <a:off x="3963924" y="8897417"/>
             <a:ext cx="3058668" cy="155448"/>
           </a:xfrm>
           <a:prstGeom prst="rect">
@@ -2798,13 +2840,13 @@
       </p:sp>
       <p:sp>
         <p:nvSpPr>
-          <p:cNvPr id="49" name="Text 44"/>
-          <p:cNvSpPr txBox="1"/>
-          <p:nvPr/>
-        </p:nvSpPr>
-        <p:spPr>
-          <a:xfrm>
-            <a:off x="3963924" y="9060282"/>
+          <p:cNvPr id="50" name="Text 45"/>
+          <p:cNvSpPr txBox="1"/>
+          <p:nvPr/>
+        </p:nvSpPr>
+        <p:spPr>
+          <a:xfrm>
+            <a:off x="3963924" y="9089441"/>
             <a:ext cx="3058668" cy="784479"/>
           </a:xfrm>
           <a:prstGeom prst="rect">

</xml_diff>

<commit_message>
Tesla earnings update: operating income, free cash flow and capex year-on-year context
Co-Authored-By: Claude Opus 5.5 <noreply@anthropic.com>
Claude-Session: https://claude.ai/code/session_01N4CkkntnhRz2pC9J6acWNT
</commit_message>
<xml_diff>
--- a/notes/2026-10-21-tesla-q3-results/syz-earnings/out/Earnings_Update_TSLA_Q32026.pptx
+++ b/notes/2026-10-21-tesla-q3-results/syz-earnings/out/Earnings_Update_TSLA_Q32026.pptx
@@ -1723,7 +1723,7 @@
                 <a:ea typeface="Nunito" pitchFamily="34" charset="-122"/>
                 <a:cs typeface="Nunito" pitchFamily="34" charset="-120"/>
               </a:rPr>
-              <a:t>Operating expenses keep rising with AI and robotics spending; capex to expand beyond the 2026 level.</a:t>
+              <a:t>Operating income fell 56% to USD 718m, a 2.6% margin, as AI and robotics spending lifted costs.</a:t>
             </a:r>
             <a:endParaRPr lang="en-US" sz="870" dirty="0"/>
           </a:p>
@@ -2360,13 +2360,13 @@
             <a:r>
               <a:rPr lang="en-US" sz="720" b="1" dirty="0">
                 <a:solidFill>
-                  <a:srgbClr val="4B5F80"/>
-                </a:solidFill>
-                <a:latin typeface="Nunito" pitchFamily="34" charset="0"/>
-                <a:ea typeface="Nunito" pitchFamily="34" charset="-122"/>
-                <a:cs typeface="Nunito" pitchFamily="34" charset="-120"/>
-              </a:rPr>
-              <a:t>Capex guide about USD 20bn</a:t>
+                  <a:srgbClr val="FF6C0E"/>
+                </a:solidFill>
+                <a:latin typeface="Nunito" pitchFamily="34" charset="0"/>
+                <a:ea typeface="Nunito" pitchFamily="34" charset="-122"/>
+                <a:cs typeface="Nunito" pitchFamily="34" charset="-120"/>
+              </a:rPr>
+              <a:t>-62% y/y; capex +110%</a:t>
             </a:r>
             <a:endParaRPr lang="en-US" sz="720" dirty="0"/>
           </a:p>
@@ -2447,7 +2447,7 @@
                 <a:ea typeface="Nunito" pitchFamily="34" charset="-122"/>
                 <a:cs typeface="Nunito" pitchFamily="34" charset="-120"/>
               </a:rPr>
-              <a:t>The quarter was better than feared on profitability. The automotive gross margin recovered, energy and services margins rose, and free cash flow stayed positive despite heavy spending. Revenue, however, was flat and reported net income fell 43%, as research and development for autonomy, Optimus and chips keeps lifting operating expenses. The core business is stabilising, but it does not yet carry a valuation built on robotaxis and humanoid robots.</a:t>
+              <a:t>The quarter was better than feared on profitability. The automotive gross margin recovered, energy and services margins rose, and free cash flow stayed positive despite heavy spending. Revenue, however, was flat and operating income fell 56%, as research and development for autonomy, Optimus and chips keeps lifting operating expenses. The core business is stabilising, but it does not yet carry a valuation built on robotaxis and humanoid robots.</a:t>
             </a:r>
             <a:endParaRPr lang="en-US" sz="870" dirty="0"/>
           </a:p>
@@ -3194,7 +3194,7 @@
                 <a:ea typeface="Nunito" pitchFamily="34" charset="-122"/>
                 <a:cs typeface="Nunito" pitchFamily="34" charset="-120"/>
               </a:rPr>
-              <a:t>Energy gross margin jumped to 33.1% from 20.4%, but mostly on tariff refunds and warranty adjustments, which we treat as one-offs. Operating expenses rose again on AI compute, chip development and pre-production costs for Optimus, Megapack 3 and the Semi, and management expects them to keep rising until these products are commercialised. Reported net income fell 43% to USD 787m, or USD 0.22 per share, including a USD 142m loss on the SpaceX stake and a USD 290m Bitcoin gain. Free cash flow was USD 1.53bn and cash and investments exceed USD 45bn.</a:t>
+              <a:t>Total gross margin rose to 19.6% from 18.0%, but operating income fell 56% to USD 718m, a 2.6% margin against 5.8% a year earlier, as AI compute, chip development and pre-production costs for Optimus, Megapack 3 and the Semi lifted operating expenses, which management expects to keep rising until these products are commercialised. The 33.1% energy gross margin was flattered by tariff refunds. Net income fell 43% to USD 787m, or USD 0.22 per share. Free cash flow fell 62% to USD 1.53bn as capex more than doubled to USD 4.7bn; cash and investments exceed USD 45bn.</a:t>
             </a:r>
             <a:endParaRPr lang="en-US" sz="870" dirty="0"/>
           </a:p>

</xml_diff>

<commit_message>
Tesla earnings update: new title and SpaceX merger focus
Co-Authored-By: Claude Opus 5.5 <noreply@anthropic.com>
Claude-Session: https://claude.ai/code/session_01N4CkkntnhRz2pC9J6acWNT
</commit_message>
<xml_diff>
--- a/notes/2026-10-21-tesla-q3-results/syz-earnings/out/Earnings_Update_TSLA_Q32026.pptx
+++ b/notes/2026-10-21-tesla-q3-results/syz-earnings/out/Earnings_Update_TSLA_Q32026.pptx
@@ -1254,7 +1254,7 @@
                 <a:ea typeface="Nunito" pitchFamily="34" charset="-122"/>
                 <a:cs typeface="Nunito" pitchFamily="34" charset="-120"/>
               </a:rPr>
-              <a:t>Tesla Q3 2026: margins recover, the valuation still rides on AI</a:t>
+              <a:t>Tesla Q3 2026: margins up, profit down, all eyes on SpaceX</a:t>
             </a:r>
             <a:endParaRPr lang="en-US" sz="1700" dirty="0"/>
           </a:p>
@@ -2405,7 +2405,7 @@
                 <a:ea typeface="Nunito" pitchFamily="34" charset="-122"/>
                 <a:cs typeface="Nunito" pitchFamily="34" charset="-120"/>
               </a:rPr>
-              <a:t>Margins buy time for the AI investment cycle</a:t>
+              <a:t>The car business funds the AI build-out</a:t>
             </a:r>
             <a:endParaRPr lang="en-US" sz="1100" dirty="0"/>
           </a:p>
@@ -2689,7 +2689,7 @@
                 <a:ea typeface="Nunito" pitchFamily="34" charset="-122"/>
                 <a:cs typeface="Nunito" pitchFamily="34" charset="-120"/>
               </a:rPr>
-              <a:t>Our stance on Tesla is neutral and cautious: USD 1.53bn of free cash flow and over USD 45bn of cash fund the build-out, but do not justify the multiple. The car business is stabilising, with the highest order backlog in four years, but the earnings base remains thin: 12-month forward consensus EPS is only USD 1.73. The valuation rests on autonomy, Optimus and the Terafab chip project, none yet generating revenue at scale, while capex will keep rising. Results move the share sharply: it fell 14.5% after the July print. The next tests are EU approval of Full Self-Driving and Cybercab launches beyond Austin.</a:t>
+              <a:t>Our stance on Tesla is neutral and cautious. The car business is stabilising, with the highest backlog in four years, but the earnings base remains thin, with 12-month forward consensus EPS of USD 1.73, while the valuation rests on autonomy, Optimus and the Terafab chip project. All eyes are now on a possible combination with SpaceX: both boards have formed special committees of independent directors and Elon Musk calls it a good idea, but no terms exist and management declined to discuss it on the call. The next tests are EU approval of Full Self-Driving and Cybercab launches beyond Austin.</a:t>
             </a:r>
             <a:endParaRPr lang="en-US" sz="870" dirty="0"/>
           </a:p>
@@ -3275,7 +3275,7 @@
                 <a:ea typeface="Nunito" pitchFamily="34" charset="-122"/>
                 <a:cs typeface="Nunito" pitchFamily="34" charset="-120"/>
               </a:rPr>
-              <a:t>Capex guidance for 2026 was revised to about USD 20bn, funded mainly from operating cash flow, but management expects capex to keep expanding for several years with the robotaxi fleet, Optimus, solar, compute and a chip fab. Tesla secured USD 30bn of credit lines, undrawn this year. The Terafab will need tens of billions of dollars by early 2028 and over USD 100bn in the long run, shared with SpaceX in proportions still open. The CFO expects robotaxis to become a significant part of revenue and profit in 2027, and external Optimus deliveries are targeted around the end of 2027. A potential SpaceX merger was not discussed.</a:t>
+              <a:t>Capex guidance for 2026 was revised to about USD 20bn, but management expects capex to keep expanding for several years with the robotaxi fleet, Optimus, solar, compute and a chip fab. Tesla secured USD 30bn of credit lines, undrawn this year. The Terafab will need tens of billions of dollars by early 2028 and over USD 100bn in the long run, partly shared with SpaceX. The CFO expects robotaxis to become a significant part of revenue and profit in 2027, and external Optimus deliveries are targeted around the end of 2027. Management declined to discuss a SpaceX merger, after both boards formed special committees on 20 October.</a:t>
             </a:r>
             <a:endParaRPr lang="en-US" sz="870" dirty="0"/>
           </a:p>

</xml_diff>